<commit_message>
Update 라이어 게임 assets and add ZIP slides
Co-Authored-By: Claude Opus 4.6 (1M context) <noreply@anthropic.com>
</commit_message>
<xml_diff>
--- a/public/downloads/games/liar-game/rules.pptx
+++ b/public/downloads/games/liar-game/rules.pptx
@@ -18,16 +18,12 @@
   <p:notesSz cx="6858000" cy="9144000"/>
   <p:embeddedFontLst>
     <p:embeddedFont>
-      <p:font typeface="Jua" charset="1" panose="00000000000000000000"/>
+      <p:font typeface="무궁화 고딕" charset="1" panose="02020603020101020101"/>
       <p:regular r:id="rId14"/>
     </p:embeddedFont>
     <p:embeddedFont>
-      <p:font typeface="TDTD갬성명조" charset="1" panose="02000503000000000000"/>
+      <p:font typeface="무궁화 고딕 Bold" charset="1" panose="02020603020101020101"/>
       <p:regular r:id="rId15"/>
-    </p:embeddedFont>
-    <p:embeddedFont>
-      <p:font typeface="TDTD가온" charset="1" panose="02000503000000000000"/>
-      <p:regular r:id="rId16"/>
     </p:embeddedFont>
   </p:embeddedFontLst>
   <p:defaultTextStyle>
@@ -3145,8 +3141,8 @@
         </p:nvSpPr>
         <p:spPr>
           <a:xfrm rot="0">
-            <a:off x="1028700" y="3892867"/>
-            <a:ext cx="15555091" cy="2200275"/>
+            <a:off x="1028700" y="4178617"/>
+            <a:ext cx="15555091" cy="1914525"/>
           </a:xfrm>
           <a:prstGeom prst="rect">
             <a:avLst/>
@@ -3168,10 +3164,10 @@
                 <a:solidFill>
                   <a:srgbClr val="FFFAEF"/>
                 </a:solidFill>
-                <a:latin typeface="Jua"/>
-                <a:ea typeface="Jua"/>
-                <a:cs typeface="Jua"/>
-                <a:sym typeface="Jua"/>
+                <a:latin typeface="무궁화 고딕"/>
+                <a:ea typeface="무궁화 고딕"/>
+                <a:cs typeface="무궁화 고딕"/>
+                <a:sym typeface="무궁화 고딕"/>
               </a:rPr>
               <a:t>라이어 게임</a:t>
             </a:r>
@@ -3186,8 +3182,8 @@
         </p:nvSpPr>
         <p:spPr>
           <a:xfrm rot="0">
-            <a:off x="15264803" y="9812655"/>
-            <a:ext cx="2637975" cy="474345"/>
+            <a:off x="14121803" y="9822180"/>
+            <a:ext cx="3780975" cy="464820"/>
           </a:xfrm>
           <a:prstGeom prst="rect">
             <a:avLst/>
@@ -3212,10 +3208,10 @@
                 <a:solidFill>
                   <a:srgbClr val="FFFFFF"/>
                 </a:solidFill>
-                <a:latin typeface="TDTD갬성명조"/>
-                <a:ea typeface="TDTD갬성명조"/>
-                <a:cs typeface="TDTD갬성명조"/>
-                <a:sym typeface="TDTD갬성명조"/>
+                <a:latin typeface="무궁화 고딕"/>
+                <a:ea typeface="무궁화 고딕"/>
+                <a:cs typeface="무궁화 고딕"/>
+                <a:sym typeface="무궁화 고딕"/>
               </a:rPr>
               <a:t>ⓒ 2026. Sunday Play</a:t>
             </a:r>
@@ -3364,8 +3360,8 @@
         </p:nvSpPr>
         <p:spPr>
           <a:xfrm rot="0">
-            <a:off x="11392761" y="600705"/>
-            <a:ext cx="5362043" cy="1600200"/>
+            <a:off x="11392761" y="819780"/>
+            <a:ext cx="5362043" cy="1381125"/>
           </a:xfrm>
           <a:prstGeom prst="rect">
             <a:avLst/>
@@ -3387,10 +3383,10 @@
                 <a:solidFill>
                   <a:srgbClr val="FFFAEF"/>
                 </a:solidFill>
-                <a:latin typeface="Jua"/>
-                <a:ea typeface="Jua"/>
-                <a:cs typeface="Jua"/>
-                <a:sym typeface="Jua"/>
+                <a:latin typeface="무궁화 고딕"/>
+                <a:ea typeface="무궁화 고딕"/>
+                <a:cs typeface="무궁화 고딕"/>
+                <a:sym typeface="무궁화 고딕"/>
               </a:rPr>
               <a:t>규칙</a:t>
             </a:r>
@@ -3406,9 +3402,9 @@
         <p:grpSpPr>
           <a:xfrm rot="0">
             <a:off x="309172" y="535073"/>
-            <a:ext cx="11259176" cy="2541713"/>
+            <a:ext cx="11259176" cy="2388758"/>
             <a:chOff x="0" y="0"/>
-            <a:chExt cx="15012235" cy="3388950"/>
+            <a:chExt cx="15012235" cy="3185010"/>
           </a:xfrm>
         </p:grpSpPr>
         <p:sp>
@@ -3419,8 +3415,8 @@
           </p:nvSpPr>
           <p:spPr>
             <a:xfrm rot="0">
-              <a:off x="0" y="1457979"/>
-              <a:ext cx="15012235" cy="1930971"/>
+              <a:off x="0" y="1449978"/>
+              <a:ext cx="15012235" cy="1735032"/>
             </a:xfrm>
             <a:prstGeom prst="rect">
               <a:avLst/>
@@ -3434,28 +3430,40 @@
             <a:p>
               <a:pPr algn="l">
                 <a:lnSpc>
-                  <a:spcPts val="5943"/>
+                  <a:spcPts val="5320"/>
                 </a:lnSpc>
               </a:pPr>
               <a:r>
-                <a:rPr lang="en-US" sz="4245">
+                <a:rPr lang="en-US" sz="3800">
                   <a:solidFill>
                     <a:srgbClr val="FFFAEF"/>
                   </a:solidFill>
-                  <a:latin typeface="TDTD가온"/>
-                  <a:ea typeface="TDTD가온"/>
-                  <a:cs typeface="TDTD가온"/>
-                  <a:sym typeface="TDTD가온"/>
+                  <a:latin typeface="무궁화 고딕"/>
+                  <a:ea typeface="무궁화 고딕"/>
+                  <a:cs typeface="무궁화 고딕"/>
+                  <a:sym typeface="무궁화 고딕"/>
                 </a:rPr>
-                <a:t>쪽지를 받고 확인합니다. 다른 사람에게 보여주지 마세요!</a:t>
+                <a:t>쪽지를 받고 확인합니다.</a:t>
               </a:r>
             </a:p>
             <a:p>
               <a:pPr algn="l">
                 <a:lnSpc>
-                  <a:spcPts val="5943"/>
+                  <a:spcPts val="5320"/>
                 </a:lnSpc>
               </a:pPr>
+              <a:r>
+                <a:rPr lang="en-US" sz="3800">
+                  <a:solidFill>
+                    <a:srgbClr val="FFFAEF"/>
+                  </a:solidFill>
+                  <a:latin typeface="무궁화 고딕"/>
+                  <a:ea typeface="무궁화 고딕"/>
+                  <a:cs typeface="무궁화 고딕"/>
+                  <a:sym typeface="무궁화 고딕"/>
+                </a:rPr>
+                <a:t>다른 사람에게 보여주지 마세요!</a:t>
+              </a:r>
             </a:p>
           </p:txBody>
         </p:sp>
@@ -3467,8 +3475,8 @@
           </p:nvSpPr>
           <p:spPr>
             <a:xfrm rot="0">
-              <a:off x="0" y="-171450"/>
-              <a:ext cx="10080302" cy="1221882"/>
+              <a:off x="0" y="-57150"/>
+              <a:ext cx="10080302" cy="1099581"/>
             </a:xfrm>
             <a:prstGeom prst="rect">
               <a:avLst/>
@@ -3490,10 +3498,10 @@
                   <a:solidFill>
                     <a:srgbClr val="FFFAEF"/>
                   </a:solidFill>
-                  <a:latin typeface="Jua"/>
-                  <a:ea typeface="Jua"/>
-                  <a:cs typeface="Jua"/>
-                  <a:sym typeface="Jua"/>
+                  <a:latin typeface="무궁화 고딕 Bold"/>
+                  <a:ea typeface="무궁화 고딕 Bold"/>
+                  <a:cs typeface="무궁화 고딕 Bold"/>
+                  <a:sym typeface="무궁화 고딕 Bold"/>
                 </a:rPr>
                 <a:t>STEP 1.</a:t>
               </a:r>
@@ -3509,10 +3517,10 @@
         </p:nvGrpSpPr>
         <p:grpSpPr>
           <a:xfrm rot="0">
-            <a:off x="8762767" y="6934481"/>
-            <a:ext cx="9364812" cy="3868911"/>
+            <a:off x="8762767" y="7054797"/>
+            <a:ext cx="9364812" cy="3567982"/>
             <a:chOff x="0" y="0"/>
-            <a:chExt cx="12486417" cy="5158548"/>
+            <a:chExt cx="12486417" cy="4757309"/>
           </a:xfrm>
         </p:grpSpPr>
         <p:sp>
@@ -3523,8 +3531,8 @@
           </p:nvSpPr>
           <p:spPr>
             <a:xfrm rot="0">
-              <a:off x="0" y="1390803"/>
-              <a:ext cx="12486417" cy="3767744"/>
+              <a:off x="0" y="1399429"/>
+              <a:ext cx="12486417" cy="3357880"/>
             </a:xfrm>
             <a:prstGeom prst="rect">
               <a:avLst/>
@@ -3538,18 +3546,18 @@
             <a:p>
               <a:pPr algn="l">
                 <a:lnSpc>
-                  <a:spcPts val="5707"/>
+                  <a:spcPts val="5040"/>
                 </a:lnSpc>
               </a:pPr>
               <a:r>
-                <a:rPr lang="en-US" sz="4076">
+                <a:rPr lang="en-US" sz="3600">
                   <a:solidFill>
                     <a:srgbClr val="FFFAEF"/>
                   </a:solidFill>
-                  <a:latin typeface="TDTD가온"/>
-                  <a:ea typeface="TDTD가온"/>
-                  <a:cs typeface="TDTD가온"/>
-                  <a:sym typeface="TDTD가온"/>
+                  <a:latin typeface="무궁화 고딕"/>
+                  <a:ea typeface="무궁화 고딕"/>
+                  <a:cs typeface="무궁화 고딕"/>
+                  <a:sym typeface="무궁화 고딕"/>
                 </a:rPr>
                 <a:t>토론 후 동시에 라이어를 지목!</a:t>
               </a:r>
@@ -3557,18 +3565,18 @@
             <a:p>
               <a:pPr algn="l">
                 <a:lnSpc>
-                  <a:spcPts val="5707"/>
+                  <a:spcPts val="5040"/>
                 </a:lnSpc>
               </a:pPr>
               <a:r>
-                <a:rPr lang="en-US" sz="4076">
+                <a:rPr lang="en-US" sz="3600">
                   <a:solidFill>
                     <a:srgbClr val="FFFAEF"/>
                   </a:solidFill>
-                  <a:latin typeface="TDTD가온"/>
-                  <a:ea typeface="TDTD가온"/>
-                  <a:cs typeface="TDTD가온"/>
-                  <a:sym typeface="TDTD가온"/>
+                  <a:latin typeface="무궁화 고딕"/>
+                  <a:ea typeface="무궁화 고딕"/>
+                  <a:cs typeface="무궁화 고딕"/>
+                  <a:sym typeface="무궁화 고딕"/>
                 </a:rPr>
                 <a:t>라이어를 찾으면 시민 승리, 못 찾으면 라이어 승리!</a:t>
               </a:r>
@@ -3576,18 +3584,18 @@
             <a:p>
               <a:pPr algn="l">
                 <a:lnSpc>
-                  <a:spcPts val="5707"/>
+                  <a:spcPts val="5040"/>
                 </a:lnSpc>
               </a:pPr>
               <a:r>
-                <a:rPr lang="en-US" sz="4076">
+                <a:rPr lang="en-US" sz="3600">
                   <a:solidFill>
                     <a:srgbClr val="FFFAEF"/>
                   </a:solidFill>
-                  <a:latin typeface="TDTD가온"/>
-                  <a:ea typeface="TDTD가온"/>
-                  <a:cs typeface="TDTD가온"/>
-                  <a:sym typeface="TDTD가온"/>
+                  <a:latin typeface="무궁화 고딕"/>
+                  <a:ea typeface="무궁화 고딕"/>
+                  <a:cs typeface="무궁화 고딕"/>
+                  <a:sym typeface="무궁화 고딕"/>
                 </a:rPr>
                 <a:t>(라이어가 들켜도 단어를 맞추면 역전 승리!)</a:t>
               </a:r>
@@ -3595,7 +3603,7 @@
             <a:p>
               <a:pPr algn="l">
                 <a:lnSpc>
-                  <a:spcPts val="5707"/>
+                  <a:spcPts val="5040"/>
                 </a:lnSpc>
               </a:pPr>
             </a:p>
@@ -3609,8 +3617,8 @@
           </p:nvSpPr>
           <p:spPr>
             <a:xfrm rot="0">
-              <a:off x="0" y="-171450"/>
-              <a:ext cx="12486417" cy="1180170"/>
+              <a:off x="0" y="-57150"/>
+              <a:ext cx="12486417" cy="1064971"/>
             </a:xfrm>
             <a:prstGeom prst="rect">
               <a:avLst/>
@@ -3628,14 +3636,14 @@
                 </a:lnSpc>
               </a:pPr>
               <a:r>
-                <a:rPr lang="en-US" sz="4983">
+                <a:rPr lang="en-US" sz="4982">
                   <a:solidFill>
                     <a:srgbClr val="FFFAEF"/>
                   </a:solidFill>
-                  <a:latin typeface="Jua"/>
-                  <a:ea typeface="Jua"/>
-                  <a:cs typeface="Jua"/>
-                  <a:sym typeface="Jua"/>
+                  <a:latin typeface="무궁화 고딕 Bold"/>
+                  <a:ea typeface="무궁화 고딕 Bold"/>
+                  <a:cs typeface="무궁화 고딕 Bold"/>
+                  <a:sym typeface="무궁화 고딕 Bold"/>
                 </a:rPr>
                 <a:t>STEP 3.</a:t>
               </a:r>
@@ -3651,10 +3659,10 @@
         </p:nvGrpSpPr>
         <p:grpSpPr>
           <a:xfrm rot="0">
-            <a:off x="4285105" y="3076785"/>
-            <a:ext cx="8674303" cy="3938856"/>
+            <a:off x="4335378" y="3476726"/>
+            <a:ext cx="8854776" cy="3025175"/>
             <a:chOff x="0" y="0"/>
-            <a:chExt cx="11565737" cy="5251808"/>
+            <a:chExt cx="11806369" cy="4033567"/>
           </a:xfrm>
         </p:grpSpPr>
         <p:sp>
@@ -3665,8 +3673,8 @@
           </p:nvSpPr>
           <p:spPr>
             <a:xfrm rot="0">
-              <a:off x="0" y="1417497"/>
-              <a:ext cx="11565737" cy="3834311"/>
+              <a:off x="0" y="1409535"/>
+              <a:ext cx="11806369" cy="2624032"/>
             </a:xfrm>
             <a:prstGeom prst="rect">
               <a:avLst/>
@@ -3680,18 +3688,18 @@
             <a:p>
               <a:pPr algn="l">
                 <a:lnSpc>
-                  <a:spcPts val="5810"/>
+                  <a:spcPts val="5320"/>
                 </a:lnSpc>
               </a:pPr>
               <a:r>
-                <a:rPr lang="en-US" sz="4150">
+                <a:rPr lang="en-US" sz="3800">
                   <a:solidFill>
                     <a:srgbClr val="FFFAEF"/>
                   </a:solidFill>
-                  <a:latin typeface="TDTD가온"/>
-                  <a:ea typeface="TDTD가온"/>
-                  <a:cs typeface="TDTD가온"/>
-                  <a:sym typeface="TDTD가온"/>
+                  <a:latin typeface="무궁화 고딕"/>
+                  <a:ea typeface="무궁화 고딕"/>
+                  <a:cs typeface="무궁화 고딕"/>
+                  <a:sym typeface="무궁화 고딕"/>
                 </a:rPr>
                 <a:t>돌아가며 단어에 대해 한 마디씩 설명합니다.</a:t>
               </a:r>
@@ -3699,47 +3707,40 @@
             <a:p>
               <a:pPr algn="l">
                 <a:lnSpc>
-                  <a:spcPts val="5810"/>
+                  <a:spcPts val="5320"/>
                 </a:lnSpc>
               </a:pPr>
               <a:r>
-                <a:rPr lang="en-US" sz="4150">
+                <a:rPr lang="en-US" sz="3800">
                   <a:solidFill>
                     <a:srgbClr val="FFFAEF"/>
                   </a:solidFill>
-                  <a:latin typeface="TDTD가온"/>
-                  <a:ea typeface="TDTD가온"/>
-                  <a:cs typeface="TDTD가온"/>
-                  <a:sym typeface="TDTD가온"/>
+                  <a:latin typeface="무궁화 고딕"/>
+                  <a:ea typeface="무궁화 고딕"/>
+                  <a:cs typeface="무궁화 고딕"/>
+                  <a:sym typeface="무궁화 고딕"/>
                 </a:rPr>
-                <a:t> 너무 직접적이면 라이어에게 힌트를,</a:t>
+                <a:t>너무 직접적이면 라이어에게 힌트를,</a:t>
               </a:r>
             </a:p>
             <a:p>
               <a:pPr algn="l">
                 <a:lnSpc>
-                  <a:spcPts val="5810"/>
+                  <a:spcPts val="5320"/>
                 </a:lnSpc>
               </a:pPr>
               <a:r>
-                <a:rPr lang="en-US" sz="4150">
+                <a:rPr lang="en-US" sz="3800">
                   <a:solidFill>
                     <a:srgbClr val="FFFAEF"/>
                   </a:solidFill>
-                  <a:latin typeface="TDTD가온"/>
-                  <a:ea typeface="TDTD가온"/>
-                  <a:cs typeface="TDTD가온"/>
-                  <a:sym typeface="TDTD가온"/>
+                  <a:latin typeface="무궁화 고딕"/>
+                  <a:ea typeface="무궁화 고딕"/>
+                  <a:cs typeface="무궁화 고딕"/>
+                  <a:sym typeface="무궁화 고딕"/>
                 </a:rPr>
                 <a:t>너무 모호하면 의심을 받습니다!</a:t>
               </a:r>
-            </a:p>
-            <a:p>
-              <a:pPr algn="l">
-                <a:lnSpc>
-                  <a:spcPts val="5810"/>
-                </a:lnSpc>
-              </a:pPr>
             </a:p>
           </p:txBody>
         </p:sp>
@@ -3751,8 +3752,8 @@
           </p:nvSpPr>
           <p:spPr>
             <a:xfrm rot="0">
-              <a:off x="0" y="-161925"/>
-              <a:ext cx="7382661" cy="1188881"/>
+              <a:off x="0" y="-47625"/>
+              <a:ext cx="7382661" cy="1066620"/>
             </a:xfrm>
             <a:prstGeom prst="rect">
               <a:avLst/>
@@ -3774,10 +3775,10 @@
                   <a:solidFill>
                     <a:srgbClr val="FFFAEF"/>
                   </a:solidFill>
-                  <a:latin typeface="Jua"/>
-                  <a:ea typeface="Jua"/>
-                  <a:cs typeface="Jua"/>
-                  <a:sym typeface="Jua"/>
+                  <a:latin typeface="무궁화 고딕 Bold"/>
+                  <a:ea typeface="무궁화 고딕 Bold"/>
+                  <a:cs typeface="무궁화 고딕 Bold"/>
+                  <a:sym typeface="무궁화 고딕 Bold"/>
                 </a:rPr>
                 <a:t>STEP 2.</a:t>
               </a:r>
@@ -3875,8 +3876,8 @@
         </p:nvSpPr>
         <p:spPr>
           <a:xfrm rot="0">
-            <a:off x="1028700" y="3892867"/>
-            <a:ext cx="15555091" cy="2200275"/>
+            <a:off x="1028700" y="4178617"/>
+            <a:ext cx="15555091" cy="1914525"/>
           </a:xfrm>
           <a:prstGeom prst="rect">
             <a:avLst/>
@@ -3898,10 +3899,10 @@
                 <a:solidFill>
                   <a:srgbClr val="FFFAEF"/>
                 </a:solidFill>
-                <a:latin typeface="Jua"/>
-                <a:ea typeface="Jua"/>
-                <a:cs typeface="Jua"/>
-                <a:sym typeface="Jua"/>
+                <a:latin typeface="무궁화 고딕"/>
+                <a:ea typeface="무궁화 고딕"/>
+                <a:cs typeface="무궁화 고딕"/>
+                <a:sym typeface="무궁화 고딕"/>
               </a:rPr>
               <a:t>라이어 게임</a:t>
             </a:r>
@@ -3916,8 +3917,8 @@
         </p:nvSpPr>
         <p:spPr>
           <a:xfrm rot="0">
-            <a:off x="15264803" y="9812655"/>
-            <a:ext cx="2637975" cy="474345"/>
+            <a:off x="14121803" y="9822180"/>
+            <a:ext cx="3780975" cy="464820"/>
           </a:xfrm>
           <a:prstGeom prst="rect">
             <a:avLst/>
@@ -3942,10 +3943,10 @@
                 <a:solidFill>
                   <a:srgbClr val="FFFFFF"/>
                 </a:solidFill>
-                <a:latin typeface="TDTD갬성명조"/>
-                <a:ea typeface="TDTD갬성명조"/>
-                <a:cs typeface="TDTD갬성명조"/>
-                <a:sym typeface="TDTD갬성명조"/>
+                <a:latin typeface="무궁화 고딕"/>
+                <a:ea typeface="무궁화 고딕"/>
+                <a:cs typeface="무궁화 고딕"/>
+                <a:sym typeface="무궁화 고딕"/>
               </a:rPr>
               <a:t>ⓒ 2026. Sunday Play</a:t>
             </a:r>
@@ -3992,8 +3993,8 @@
         </p:nvSpPr>
         <p:spPr>
           <a:xfrm rot="0">
-            <a:off x="3238925" y="4092795"/>
-            <a:ext cx="11810151" cy="2200275"/>
+            <a:off x="3238925" y="4378545"/>
+            <a:ext cx="11810151" cy="1914525"/>
           </a:xfrm>
           <a:prstGeom prst="rect">
             <a:avLst/>
@@ -4015,10 +4016,10 @@
                 <a:solidFill>
                   <a:srgbClr val="000000"/>
                 </a:solidFill>
-                <a:latin typeface="Jua"/>
-                <a:ea typeface="Jua"/>
-                <a:cs typeface="Jua"/>
-                <a:sym typeface="Jua"/>
+                <a:latin typeface="무궁화 고딕"/>
+                <a:ea typeface="무궁화 고딕"/>
+                <a:cs typeface="무궁화 고딕"/>
+                <a:sym typeface="무궁화 고딕"/>
               </a:rPr>
               <a:t>주제 : 음식</a:t>
             </a:r>
@@ -4115,8 +4116,8 @@
         </p:nvSpPr>
         <p:spPr>
           <a:xfrm rot="0">
-            <a:off x="3238925" y="4092795"/>
-            <a:ext cx="11810151" cy="2200275"/>
+            <a:off x="3238925" y="4378545"/>
+            <a:ext cx="11810151" cy="1914525"/>
           </a:xfrm>
           <a:prstGeom prst="rect">
             <a:avLst/>
@@ -4138,10 +4139,10 @@
                 <a:solidFill>
                   <a:srgbClr val="000000"/>
                 </a:solidFill>
-                <a:latin typeface="Jua"/>
-                <a:ea typeface="Jua"/>
-                <a:cs typeface="Jua"/>
-                <a:sym typeface="Jua"/>
+                <a:latin typeface="무궁화 고딕"/>
+                <a:ea typeface="무궁화 고딕"/>
+                <a:cs typeface="무궁화 고딕"/>
+                <a:sym typeface="무궁화 고딕"/>
               </a:rPr>
               <a:t>주제 : 장소</a:t>
             </a:r>
@@ -4238,8 +4239,8 @@
         </p:nvSpPr>
         <p:spPr>
           <a:xfrm rot="0">
-            <a:off x="3238925" y="4092795"/>
-            <a:ext cx="11810151" cy="2200275"/>
+            <a:off x="3238925" y="4378545"/>
+            <a:ext cx="11810151" cy="1914525"/>
           </a:xfrm>
           <a:prstGeom prst="rect">
             <a:avLst/>
@@ -4261,10 +4262,10 @@
                 <a:solidFill>
                   <a:srgbClr val="000000"/>
                 </a:solidFill>
-                <a:latin typeface="Jua"/>
-                <a:ea typeface="Jua"/>
-                <a:cs typeface="Jua"/>
-                <a:sym typeface="Jua"/>
+                <a:latin typeface="무궁화 고딕"/>
+                <a:ea typeface="무궁화 고딕"/>
+                <a:cs typeface="무궁화 고딕"/>
+                <a:sym typeface="무궁화 고딕"/>
               </a:rPr>
               <a:t>주제 : 동물</a:t>
             </a:r>
@@ -4361,8 +4362,8 @@
         </p:nvSpPr>
         <p:spPr>
           <a:xfrm rot="0">
-            <a:off x="3238925" y="4092795"/>
-            <a:ext cx="11810151" cy="2200275"/>
+            <a:off x="3238925" y="4378545"/>
+            <a:ext cx="11810151" cy="1914525"/>
           </a:xfrm>
           <a:prstGeom prst="rect">
             <a:avLst/>
@@ -4384,10 +4385,10 @@
                 <a:solidFill>
                   <a:srgbClr val="000000"/>
                 </a:solidFill>
-                <a:latin typeface="Jua"/>
-                <a:ea typeface="Jua"/>
-                <a:cs typeface="Jua"/>
-                <a:sym typeface="Jua"/>
+                <a:latin typeface="무궁화 고딕"/>
+                <a:ea typeface="무궁화 고딕"/>
+                <a:cs typeface="무궁화 고딕"/>
+                <a:sym typeface="무궁화 고딕"/>
               </a:rPr>
               <a:t>주제 : 직업</a:t>
             </a:r>
@@ -4509,8 +4510,8 @@
         </p:nvSpPr>
         <p:spPr>
           <a:xfrm rot="0">
-            <a:off x="4421807" y="3895725"/>
-            <a:ext cx="9444385" cy="2200275"/>
+            <a:off x="4421807" y="4181475"/>
+            <a:ext cx="9444385" cy="1914525"/>
           </a:xfrm>
           <a:prstGeom prst="rect">
             <a:avLst/>
@@ -4532,10 +4533,10 @@
                 <a:solidFill>
                   <a:srgbClr val="000000"/>
                 </a:solidFill>
-                <a:latin typeface="Jua"/>
-                <a:ea typeface="Jua"/>
-                <a:cs typeface="Jua"/>
-                <a:sym typeface="Jua"/>
+                <a:latin typeface="무궁화 고딕"/>
+                <a:ea typeface="무궁화 고딕"/>
+                <a:cs typeface="무궁화 고딕"/>
+                <a:sym typeface="무궁화 고딕"/>
               </a:rPr>
               <a:t>감사합니다!</a:t>
             </a:r>

</xml_diff>